<commit_message>
Rebuild session8 deck with the background-copy fix
Regenerated locally with the corrected pptx_helpers.duplicate_slide (see
d369ff3) -- all 32 slides now carry the template's near-black background,
so the title/subtitle text is readable instead of white-on-white.
</commit_message>
<xml_diff>
--- a/session8/Hive_Pig_Hadoop_Ecosystem.pptx
+++ b/session8/Hive_Pig_Hadoop_Ecosystem.pptx
@@ -5705,6 +5705,14 @@
 <file path=ppt/slides/slide13.xml><?xml version="1.0" encoding="utf-8"?>
 <p:sld xmlns:a="http://schemas.openxmlformats.org/drawingml/2006/main" xmlns:p="http://schemas.openxmlformats.org/presentationml/2006/main" xmlns:r="http://schemas.openxmlformats.org/officeDocument/2006/relationships">
   <p:cSld>
+    <p:bg>
+      <p:bgPr>
+        <a:solidFill>
+          <a:srgbClr val="0B0B0C"/>
+        </a:solidFill>
+        <a:effectLst/>
+      </p:bgPr>
+    </p:bg>
     <p:spTree>
       <p:nvGrpSpPr>
         <p:cNvPr id="1" name=""/>
@@ -5845,6 +5853,14 @@
 <file path=ppt/slides/slide14.xml><?xml version="1.0" encoding="utf-8"?>
 <p:sld xmlns:a="http://schemas.openxmlformats.org/drawingml/2006/main" xmlns:p="http://schemas.openxmlformats.org/presentationml/2006/main" xmlns:r="http://schemas.openxmlformats.org/officeDocument/2006/relationships">
   <p:cSld>
+    <p:bg>
+      <p:bgPr>
+        <a:solidFill>
+          <a:srgbClr val="0B0B0C"/>
+        </a:solidFill>
+        <a:effectLst/>
+      </p:bgPr>
+    </p:bg>
     <p:spTree>
       <p:nvGrpSpPr>
         <p:cNvPr id="1" name=""/>
@@ -5967,6 +5983,14 @@
 <file path=ppt/slides/slide15.xml><?xml version="1.0" encoding="utf-8"?>
 <p:sld xmlns:a="http://schemas.openxmlformats.org/drawingml/2006/main" xmlns:p="http://schemas.openxmlformats.org/presentationml/2006/main" xmlns:r="http://schemas.openxmlformats.org/officeDocument/2006/relationships">
   <p:cSld>
+    <p:bg>
+      <p:bgPr>
+        <a:solidFill>
+          <a:srgbClr val="0B0B0C"/>
+        </a:solidFill>
+        <a:effectLst/>
+      </p:bgPr>
+    </p:bg>
     <p:spTree>
       <p:nvGrpSpPr>
         <p:cNvPr id="1" name=""/>
@@ -6027,6 +6051,14 @@
 <file path=ppt/slides/slide16.xml><?xml version="1.0" encoding="utf-8"?>
 <p:sld xmlns:a="http://schemas.openxmlformats.org/drawingml/2006/main" xmlns:p="http://schemas.openxmlformats.org/presentationml/2006/main" xmlns:r="http://schemas.openxmlformats.org/officeDocument/2006/relationships">
   <p:cSld>
+    <p:bg>
+      <p:bgPr>
+        <a:solidFill>
+          <a:srgbClr val="0B0B0C"/>
+        </a:solidFill>
+        <a:effectLst/>
+      </p:bgPr>
+    </p:bg>
     <p:spTree>
       <p:nvGrpSpPr>
         <p:cNvPr id="1" name=""/>
@@ -6210,6 +6242,14 @@
 <file path=ppt/slides/slide17.xml><?xml version="1.0" encoding="utf-8"?>
 <p:sld xmlns:a="http://schemas.openxmlformats.org/drawingml/2006/main" xmlns:p="http://schemas.openxmlformats.org/presentationml/2006/main" xmlns:r="http://schemas.openxmlformats.org/officeDocument/2006/relationships">
   <p:cSld>
+    <p:bg>
+      <p:bgPr>
+        <a:solidFill>
+          <a:srgbClr val="0B0B0C"/>
+        </a:solidFill>
+        <a:effectLst/>
+      </p:bgPr>
+    </p:bg>
     <p:spTree>
       <p:nvGrpSpPr>
         <p:cNvPr id="1" name=""/>
@@ -6743,6 +6783,14 @@
 <file path=ppt/slides/slide18.xml><?xml version="1.0" encoding="utf-8"?>
 <p:sld xmlns:a="http://schemas.openxmlformats.org/drawingml/2006/main" xmlns:p="http://schemas.openxmlformats.org/presentationml/2006/main" xmlns:r="http://schemas.openxmlformats.org/officeDocument/2006/relationships">
   <p:cSld>
+    <p:bg>
+      <p:bgPr>
+        <a:solidFill>
+          <a:srgbClr val="0B0B0C"/>
+        </a:solidFill>
+        <a:effectLst/>
+      </p:bgPr>
+    </p:bg>
     <p:spTree>
       <p:nvGrpSpPr>
         <p:cNvPr id="1" name=""/>
@@ -7015,6 +7063,14 @@
 <file path=ppt/slides/slide19.xml><?xml version="1.0" encoding="utf-8"?>
 <p:sld xmlns:a="http://schemas.openxmlformats.org/drawingml/2006/main" xmlns:p="http://schemas.openxmlformats.org/presentationml/2006/main" xmlns:r="http://schemas.openxmlformats.org/officeDocument/2006/relationships">
   <p:cSld>
+    <p:bg>
+      <p:bgPr>
+        <a:solidFill>
+          <a:srgbClr val="0B0B0C"/>
+        </a:solidFill>
+        <a:effectLst/>
+      </p:bgPr>
+    </p:bg>
     <p:spTree>
       <p:nvGrpSpPr>
         <p:cNvPr id="1" name=""/>
@@ -7198,6 +7254,14 @@
 <file path=ppt/slides/slide20.xml><?xml version="1.0" encoding="utf-8"?>
 <p:sld xmlns:a="http://schemas.openxmlformats.org/drawingml/2006/main" xmlns:p="http://schemas.openxmlformats.org/presentationml/2006/main" xmlns:r="http://schemas.openxmlformats.org/officeDocument/2006/relationships">
   <p:cSld>
+    <p:bg>
+      <p:bgPr>
+        <a:solidFill>
+          <a:srgbClr val="0B0B0C"/>
+        </a:solidFill>
+        <a:effectLst/>
+      </p:bgPr>
+    </p:bg>
     <p:spTree>
       <p:nvGrpSpPr>
         <p:cNvPr id="1" name=""/>
@@ -7277,6 +7341,14 @@
 <file path=ppt/slides/slide21.xml><?xml version="1.0" encoding="utf-8"?>
 <p:sld xmlns:a="http://schemas.openxmlformats.org/drawingml/2006/main" xmlns:p="http://schemas.openxmlformats.org/presentationml/2006/main" xmlns:r="http://schemas.openxmlformats.org/officeDocument/2006/relationships">
   <p:cSld>
+    <p:bg>
+      <p:bgPr>
+        <a:solidFill>
+          <a:srgbClr val="0B0B0C"/>
+        </a:solidFill>
+        <a:effectLst/>
+      </p:bgPr>
+    </p:bg>
     <p:spTree>
       <p:nvGrpSpPr>
         <p:cNvPr id="1" name=""/>
@@ -7595,6 +7667,14 @@
 <file path=ppt/slides/slide22.xml><?xml version="1.0" encoding="utf-8"?>
 <p:sld xmlns:a="http://schemas.openxmlformats.org/drawingml/2006/main" xmlns:p="http://schemas.openxmlformats.org/presentationml/2006/main" xmlns:r="http://schemas.openxmlformats.org/officeDocument/2006/relationships">
   <p:cSld>
+    <p:bg>
+      <p:bgPr>
+        <a:solidFill>
+          <a:srgbClr val="0B0B0C"/>
+        </a:solidFill>
+        <a:effectLst/>
+      </p:bgPr>
+    </p:bg>
     <p:spTree>
       <p:nvGrpSpPr>
         <p:cNvPr id="1" name=""/>
@@ -7674,6 +7754,14 @@
 <file path=ppt/slides/slide23.xml><?xml version="1.0" encoding="utf-8"?>
 <p:sld xmlns:a="http://schemas.openxmlformats.org/drawingml/2006/main" xmlns:p="http://schemas.openxmlformats.org/presentationml/2006/main" xmlns:r="http://schemas.openxmlformats.org/officeDocument/2006/relationships">
   <p:cSld>
+    <p:bg>
+      <p:bgPr>
+        <a:solidFill>
+          <a:srgbClr val="0B0B0C"/>
+        </a:solidFill>
+        <a:effectLst/>
+      </p:bgPr>
+    </p:bg>
     <p:spTree>
       <p:nvGrpSpPr>
         <p:cNvPr id="1" name=""/>
@@ -7734,6 +7822,14 @@
 <file path=ppt/slides/slide24.xml><?xml version="1.0" encoding="utf-8"?>
 <p:sld xmlns:a="http://schemas.openxmlformats.org/drawingml/2006/main" xmlns:p="http://schemas.openxmlformats.org/presentationml/2006/main" xmlns:r="http://schemas.openxmlformats.org/officeDocument/2006/relationships">
   <p:cSld>
+    <p:bg>
+      <p:bgPr>
+        <a:solidFill>
+          <a:srgbClr val="0B0B0C"/>
+        </a:solidFill>
+        <a:effectLst/>
+      </p:bgPr>
+    </p:bg>
     <p:spTree>
       <p:nvGrpSpPr>
         <p:cNvPr id="1" name=""/>
@@ -7917,6 +8013,14 @@
 <file path=ppt/slides/slide25.xml><?xml version="1.0" encoding="utf-8"?>
 <p:sld xmlns:a="http://schemas.openxmlformats.org/drawingml/2006/main" xmlns:p="http://schemas.openxmlformats.org/presentationml/2006/main" xmlns:r="http://schemas.openxmlformats.org/officeDocument/2006/relationships">
   <p:cSld>
+    <p:bg>
+      <p:bgPr>
+        <a:solidFill>
+          <a:srgbClr val="0B0B0C"/>
+        </a:solidFill>
+        <a:effectLst/>
+      </p:bgPr>
+    </p:bg>
     <p:spTree>
       <p:nvGrpSpPr>
         <p:cNvPr id="1" name=""/>
@@ -8039,6 +8143,14 @@
 <file path=ppt/slides/slide26.xml><?xml version="1.0" encoding="utf-8"?>
 <p:sld xmlns:a="http://schemas.openxmlformats.org/drawingml/2006/main" xmlns:p="http://schemas.openxmlformats.org/presentationml/2006/main" xmlns:r="http://schemas.openxmlformats.org/officeDocument/2006/relationships">
   <p:cSld>
+    <p:bg>
+      <p:bgPr>
+        <a:solidFill>
+          <a:srgbClr val="0B0B0C"/>
+        </a:solidFill>
+        <a:effectLst/>
+      </p:bgPr>
+    </p:bg>
     <p:spTree>
       <p:nvGrpSpPr>
         <p:cNvPr id="1" name=""/>
@@ -8222,6 +8334,14 @@
 <file path=ppt/slides/slide27.xml><?xml version="1.0" encoding="utf-8"?>
 <p:sld xmlns:a="http://schemas.openxmlformats.org/drawingml/2006/main" xmlns:p="http://schemas.openxmlformats.org/presentationml/2006/main" xmlns:r="http://schemas.openxmlformats.org/officeDocument/2006/relationships">
   <p:cSld>
+    <p:bg>
+      <p:bgPr>
+        <a:solidFill>
+          <a:srgbClr val="0B0B0C"/>
+        </a:solidFill>
+        <a:effectLst/>
+      </p:bgPr>
+    </p:bg>
     <p:spTree>
       <p:nvGrpSpPr>
         <p:cNvPr id="1" name=""/>
@@ -8405,6 +8525,14 @@
 <file path=ppt/slides/slide28.xml><?xml version="1.0" encoding="utf-8"?>
 <p:sld xmlns:a="http://schemas.openxmlformats.org/drawingml/2006/main" xmlns:p="http://schemas.openxmlformats.org/presentationml/2006/main" xmlns:r="http://schemas.openxmlformats.org/officeDocument/2006/relationships">
   <p:cSld>
+    <p:bg>
+      <p:bgPr>
+        <a:solidFill>
+          <a:srgbClr val="0B0B0C"/>
+        </a:solidFill>
+        <a:effectLst/>
+      </p:bgPr>
+    </p:bg>
     <p:spTree>
       <p:nvGrpSpPr>
         <p:cNvPr id="1" name=""/>
@@ -8484,6 +8612,14 @@
 <file path=ppt/slides/slide29.xml><?xml version="1.0" encoding="utf-8"?>
 <p:sld xmlns:a="http://schemas.openxmlformats.org/drawingml/2006/main" xmlns:p="http://schemas.openxmlformats.org/presentationml/2006/main" xmlns:r="http://schemas.openxmlformats.org/officeDocument/2006/relationships">
   <p:cSld>
+    <p:bg>
+      <p:bgPr>
+        <a:solidFill>
+          <a:srgbClr val="0B0B0C"/>
+        </a:solidFill>
+        <a:effectLst/>
+      </p:bgPr>
+    </p:bg>
     <p:spTree>
       <p:nvGrpSpPr>
         <p:cNvPr id="1" name=""/>
@@ -8606,6 +8742,14 @@
 <file path=ppt/slides/slide30.xml><?xml version="1.0" encoding="utf-8"?>
 <p:sld xmlns:a="http://schemas.openxmlformats.org/drawingml/2006/main" xmlns:p="http://schemas.openxmlformats.org/presentationml/2006/main" xmlns:r="http://schemas.openxmlformats.org/officeDocument/2006/relationships">
   <p:cSld>
+    <p:bg>
+      <p:bgPr>
+        <a:solidFill>
+          <a:srgbClr val="0B0B0C"/>
+        </a:solidFill>
+        <a:effectLst/>
+      </p:bgPr>
+    </p:bg>
     <p:spTree>
       <p:nvGrpSpPr>
         <p:cNvPr id="1" name=""/>
@@ -8666,6 +8810,14 @@
 <file path=ppt/slides/slide31.xml><?xml version="1.0" encoding="utf-8"?>
 <p:sld xmlns:a="http://schemas.openxmlformats.org/drawingml/2006/main" xmlns:p="http://schemas.openxmlformats.org/presentationml/2006/main" xmlns:r="http://schemas.openxmlformats.org/officeDocument/2006/relationships">
   <p:cSld>
+    <p:bg>
+      <p:bgPr>
+        <a:solidFill>
+          <a:srgbClr val="0B0B0C"/>
+        </a:solidFill>
+        <a:effectLst/>
+      </p:bgPr>
+    </p:bg>
     <p:spTree>
       <p:nvGrpSpPr>
         <p:cNvPr id="1" name=""/>
@@ -8849,6 +9001,14 @@
 <file path=ppt/slides/slide32.xml><?xml version="1.0" encoding="utf-8"?>
 <p:sld xmlns:a="http://schemas.openxmlformats.org/drawingml/2006/main" xmlns:p="http://schemas.openxmlformats.org/presentationml/2006/main" xmlns:r="http://schemas.openxmlformats.org/officeDocument/2006/relationships">
   <p:cSld>
+    <p:bg>
+      <p:bgPr>
+        <a:solidFill>
+          <a:srgbClr val="0B0B0C"/>
+        </a:solidFill>
+        <a:effectLst/>
+      </p:bgPr>
+    </p:bg>
     <p:spTree>
       <p:nvGrpSpPr>
         <p:cNvPr id="1" name=""/>
@@ -9149,6 +9309,14 @@
 <file path=ppt/slides/slide33.xml><?xml version="1.0" encoding="utf-8"?>
 <p:sld xmlns:a="http://schemas.openxmlformats.org/drawingml/2006/main" xmlns:p="http://schemas.openxmlformats.org/presentationml/2006/main" xmlns:r="http://schemas.openxmlformats.org/officeDocument/2006/relationships">
   <p:cSld>
+    <p:bg>
+      <p:bgPr>
+        <a:solidFill>
+          <a:srgbClr val="0B0B0C"/>
+        </a:solidFill>
+        <a:effectLst/>
+      </p:bgPr>
+    </p:bg>
     <p:spTree>
       <p:nvGrpSpPr>
         <p:cNvPr id="1" name=""/>
@@ -9467,6 +9635,14 @@
 <file path=ppt/slides/slide34.xml><?xml version="1.0" encoding="utf-8"?>
 <p:sld xmlns:a="http://schemas.openxmlformats.org/drawingml/2006/main" xmlns:p="http://schemas.openxmlformats.org/presentationml/2006/main" xmlns:r="http://schemas.openxmlformats.org/officeDocument/2006/relationships">
   <p:cSld>
+    <p:bg>
+      <p:bgPr>
+        <a:solidFill>
+          <a:srgbClr val="0B0B0C"/>
+        </a:solidFill>
+        <a:effectLst/>
+      </p:bgPr>
+    </p:bg>
     <p:spTree>
       <p:nvGrpSpPr>
         <p:cNvPr id="1" name=""/>
@@ -9546,6 +9722,14 @@
 <file path=ppt/slides/slide35.xml><?xml version="1.0" encoding="utf-8"?>
 <p:sld xmlns:a="http://schemas.openxmlformats.org/drawingml/2006/main" xmlns:p="http://schemas.openxmlformats.org/presentationml/2006/main" xmlns:r="http://schemas.openxmlformats.org/officeDocument/2006/relationships">
   <p:cSld>
+    <p:bg>
+      <p:bgPr>
+        <a:solidFill>
+          <a:srgbClr val="0B0B0C"/>
+        </a:solidFill>
+        <a:effectLst/>
+      </p:bgPr>
+    </p:bg>
     <p:spTree>
       <p:nvGrpSpPr>
         <p:cNvPr id="1" name=""/>
@@ -9818,6 +10002,14 @@
 <file path=ppt/slides/slide36.xml><?xml version="1.0" encoding="utf-8"?>
 <p:sld xmlns:a="http://schemas.openxmlformats.org/drawingml/2006/main" xmlns:p="http://schemas.openxmlformats.org/presentationml/2006/main" xmlns:r="http://schemas.openxmlformats.org/officeDocument/2006/relationships">
   <p:cSld>
+    <p:bg>
+      <p:bgPr>
+        <a:solidFill>
+          <a:srgbClr val="0B0B0C"/>
+        </a:solidFill>
+        <a:effectLst/>
+      </p:bgPr>
+    </p:bg>
     <p:spTree>
       <p:nvGrpSpPr>
         <p:cNvPr id="1" name=""/>
@@ -9940,6 +10132,14 @@
 <file path=ppt/slides/slide37.xml><?xml version="1.0" encoding="utf-8"?>
 <p:sld xmlns:a="http://schemas.openxmlformats.org/drawingml/2006/main" xmlns:p="http://schemas.openxmlformats.org/presentationml/2006/main" xmlns:r="http://schemas.openxmlformats.org/officeDocument/2006/relationships">
   <p:cSld>
+    <p:bg>
+      <p:bgPr>
+        <a:solidFill>
+          <a:srgbClr val="0B0B0C"/>
+        </a:solidFill>
+        <a:effectLst/>
+      </p:bgPr>
+    </p:bg>
     <p:spTree>
       <p:nvGrpSpPr>
         <p:cNvPr id="1" name=""/>
@@ -10123,6 +10323,14 @@
 <file path=ppt/slides/slide38.xml><?xml version="1.0" encoding="utf-8"?>
 <p:sld xmlns:a="http://schemas.openxmlformats.org/drawingml/2006/main" xmlns:p="http://schemas.openxmlformats.org/presentationml/2006/main" xmlns:r="http://schemas.openxmlformats.org/officeDocument/2006/relationships">
   <p:cSld>
+    <p:bg>
+      <p:bgPr>
+        <a:solidFill>
+          <a:srgbClr val="0B0B0C"/>
+        </a:solidFill>
+        <a:effectLst/>
+      </p:bgPr>
+    </p:bg>
     <p:spTree>
       <p:nvGrpSpPr>
         <p:cNvPr id="1" name=""/>
@@ -10306,6 +10514,14 @@
 <file path=ppt/slides/slide39.xml><?xml version="1.0" encoding="utf-8"?>
 <p:sld xmlns:a="http://schemas.openxmlformats.org/drawingml/2006/main" xmlns:p="http://schemas.openxmlformats.org/presentationml/2006/main" xmlns:r="http://schemas.openxmlformats.org/officeDocument/2006/relationships">
   <p:cSld>
+    <p:bg>
+      <p:bgPr>
+        <a:solidFill>
+          <a:srgbClr val="0B0B0C"/>
+        </a:solidFill>
+        <a:effectLst/>
+      </p:bgPr>
+    </p:bg>
     <p:spTree>
       <p:nvGrpSpPr>
         <p:cNvPr id="1" name=""/>
@@ -10847,6 +11063,14 @@
 <file path=ppt/slides/slide40.xml><?xml version="1.0" encoding="utf-8"?>
 <p:sld xmlns:a="http://schemas.openxmlformats.org/drawingml/2006/main" xmlns:p="http://schemas.openxmlformats.org/presentationml/2006/main" xmlns:r="http://schemas.openxmlformats.org/officeDocument/2006/relationships">
   <p:cSld>
+    <p:bg>
+      <p:bgPr>
+        <a:solidFill>
+          <a:srgbClr val="0B0B0C"/>
+        </a:solidFill>
+        <a:effectLst/>
+      </p:bgPr>
+    </p:bg>
     <p:spTree>
       <p:nvGrpSpPr>
         <p:cNvPr id="1" name=""/>
@@ -10907,6 +11131,14 @@
 <file path=ppt/slides/slide41.xml><?xml version="1.0" encoding="utf-8"?>
 <p:sld xmlns:a="http://schemas.openxmlformats.org/drawingml/2006/main" xmlns:p="http://schemas.openxmlformats.org/presentationml/2006/main" xmlns:r="http://schemas.openxmlformats.org/officeDocument/2006/relationships">
   <p:cSld>
+    <p:bg>
+      <p:bgPr>
+        <a:solidFill>
+          <a:srgbClr val="0B0B0C"/>
+        </a:solidFill>
+        <a:effectLst/>
+      </p:bgPr>
+    </p:bg>
     <p:spTree>
       <p:nvGrpSpPr>
         <p:cNvPr id="1" name=""/>
@@ -10986,6 +11218,14 @@
 <file path=ppt/slides/slide42.xml><?xml version="1.0" encoding="utf-8"?>
 <p:sld xmlns:a="http://schemas.openxmlformats.org/drawingml/2006/main" xmlns:p="http://schemas.openxmlformats.org/presentationml/2006/main" xmlns:r="http://schemas.openxmlformats.org/officeDocument/2006/relationships">
   <p:cSld>
+    <p:bg>
+      <p:bgPr>
+        <a:solidFill>
+          <a:srgbClr val="0B0B0C"/>
+        </a:solidFill>
+        <a:effectLst/>
+      </p:bgPr>
+    </p:bg>
     <p:spTree>
       <p:nvGrpSpPr>
         <p:cNvPr id="1" name=""/>
@@ -11046,6 +11286,14 @@
 <file path=ppt/slides/slide43.xml><?xml version="1.0" encoding="utf-8"?>
 <p:sld xmlns:a="http://schemas.openxmlformats.org/drawingml/2006/main" xmlns:p="http://schemas.openxmlformats.org/presentationml/2006/main" xmlns:r="http://schemas.openxmlformats.org/officeDocument/2006/relationships">
   <p:cSld>
+    <p:bg>
+      <p:bgPr>
+        <a:solidFill>
+          <a:srgbClr val="0B0B0C"/>
+        </a:solidFill>
+        <a:effectLst/>
+      </p:bgPr>
+    </p:bg>
     <p:spTree>
       <p:nvGrpSpPr>
         <p:cNvPr id="1" name=""/>
@@ -11229,6 +11477,14 @@
 <file path=ppt/slides/slide44.xml><?xml version="1.0" encoding="utf-8"?>
 <p:sld xmlns:a="http://schemas.openxmlformats.org/drawingml/2006/main" xmlns:p="http://schemas.openxmlformats.org/presentationml/2006/main" xmlns:r="http://schemas.openxmlformats.org/officeDocument/2006/relationships">
   <p:cSld>
+    <p:bg>
+      <p:bgPr>
+        <a:solidFill>
+          <a:srgbClr val="0B0B0C"/>
+        </a:solidFill>
+        <a:effectLst/>
+      </p:bgPr>
+    </p:bg>
     <p:spTree>
       <p:nvGrpSpPr>
         <p:cNvPr id="1" name=""/>

</xml_diff>

<commit_message>
Flip apple-style template to light theme; add Bento design reference
Background near-black -> white, primary text near-white -> solid black,
secondary text -> mid-gray, card fills flipped to light gray. Apple-blue
accent (#0071E3) unchanged. Applied to the template asset (future builds)
and to the already-built session8 deck. Docs/comments updated to match.
Also adds bento-design-reference.pptx as an optional design reference,
not wired into the build pipeline.
</commit_message>
<xml_diff>
--- a/session8/Hive_Pig_Hadoop_Ecosystem.pptx
+++ b/session8/Hive_Pig_Hadoop_Ecosystem.pptx
@@ -5708,7 +5708,7 @@
     <p:bg>
       <p:bgPr>
         <a:solidFill>
-          <a:srgbClr val="0B0B0C"/>
+          <a:srgbClr val="FFFFFF"/>
         </a:solidFill>
         <a:effectLst/>
       </p:bgPr>
@@ -5770,7 +5770,7 @@
               </a:spcAft>
               <a:defRPr sz="6400" b="1" i="0">
                 <a:solidFill>
-                  <a:srgbClr val="F5F5F7"/>
+                  <a:srgbClr val="000000"/>
                 </a:solidFill>
                 <a:latin typeface="Helvetica Neue"/>
               </a:defRPr>
@@ -5789,7 +5789,7 @@
               </a:spcAft>
               <a:defRPr sz="2600" b="0" i="0">
                 <a:solidFill>
-                  <a:srgbClr val="A1A1A6"/>
+                  <a:srgbClr val="6E6E73"/>
                 </a:solidFill>
                 <a:latin typeface="Helvetica Neue"/>
               </a:defRPr>
@@ -5831,7 +5831,7 @@
               </a:spcAft>
               <a:defRPr sz="1500" b="0" i="0">
                 <a:solidFill>
-                  <a:srgbClr val="A1A1A6"/>
+                  <a:srgbClr val="6E6E73"/>
                 </a:solidFill>
                 <a:latin typeface="Helvetica Neue"/>
               </a:defRPr>
@@ -5856,7 +5856,7 @@
     <p:bg>
       <p:bgPr>
         <a:solidFill>
-          <a:srgbClr val="0B0B0C"/>
+          <a:srgbClr val="FFFFFF"/>
         </a:solidFill>
         <a:effectLst/>
       </p:bgPr>
@@ -5918,7 +5918,7 @@
               </a:spcAft>
               <a:defRPr sz="9600" b="1" i="0">
                 <a:solidFill>
-                  <a:srgbClr val="F5F5F7"/>
+                  <a:srgbClr val="000000"/>
                 </a:solidFill>
                 <a:latin typeface="Helvetica Neue"/>
               </a:defRPr>
@@ -5986,7 +5986,7 @@
     <p:bg>
       <p:bgPr>
         <a:solidFill>
-          <a:srgbClr val="0B0B0C"/>
+          <a:srgbClr val="FFFFFF"/>
         </a:solidFill>
         <a:effectLst/>
       </p:bgPr>
@@ -6029,7 +6029,7 @@
               </a:spcAft>
               <a:defRPr sz="5400" b="1" i="0">
                 <a:solidFill>
-                  <a:srgbClr val="F5F5F7"/>
+                  <a:srgbClr val="000000"/>
                 </a:solidFill>
                 <a:latin typeface="Helvetica Neue"/>
               </a:defRPr>
@@ -6054,7 +6054,7 @@
     <p:bg>
       <p:bgPr>
         <a:solidFill>
-          <a:srgbClr val="0B0B0C"/>
+          <a:srgbClr val="FFFFFF"/>
         </a:solidFill>
         <a:effectLst/>
       </p:bgPr>
@@ -6097,7 +6097,7 @@
               </a:spcAft>
               <a:defRPr sz="4000" b="1" i="0">
                 <a:solidFill>
-                  <a:srgbClr val="F5F5F7"/>
+                  <a:srgbClr val="000000"/>
                 </a:solidFill>
                 <a:latin typeface="Helvetica Neue"/>
               </a:defRPr>
@@ -6182,7 +6182,7 @@
               </a:spcAft>
               <a:defRPr sz="2800" b="0" i="0">
                 <a:solidFill>
-                  <a:srgbClr val="F5F5F7"/>
+                  <a:srgbClr val="000000"/>
                 </a:solidFill>
                 <a:latin typeface="Helvetica Neue"/>
               </a:defRPr>
@@ -6201,7 +6201,7 @@
               </a:spcAft>
               <a:defRPr sz="2800" b="0" i="0">
                 <a:solidFill>
-                  <a:srgbClr val="F5F5F7"/>
+                  <a:srgbClr val="000000"/>
                 </a:solidFill>
                 <a:latin typeface="Helvetica Neue"/>
               </a:defRPr>
@@ -6220,7 +6220,7 @@
               </a:spcAft>
               <a:defRPr sz="2800" b="0" i="0">
                 <a:solidFill>
-                  <a:srgbClr val="F5F5F7"/>
+                  <a:srgbClr val="000000"/>
                 </a:solidFill>
                 <a:latin typeface="Helvetica Neue"/>
               </a:defRPr>
@@ -6245,7 +6245,7 @@
     <p:bg>
       <p:bgPr>
         <a:solidFill>
-          <a:srgbClr val="0B0B0C"/>
+          <a:srgbClr val="FFFFFF"/>
         </a:solidFill>
         <a:effectLst/>
       </p:bgPr>
@@ -6288,7 +6288,7 @@
               </a:spcAft>
               <a:defRPr sz="3800" b="1" i="0">
                 <a:solidFill>
-                  <a:srgbClr val="F5F5F7"/>
+                  <a:srgbClr val="000000"/>
                 </a:solidFill>
                 <a:latin typeface="Helvetica Neue"/>
               </a:defRPr>
@@ -6316,7 +6316,7 @@
             </a:avLst>
           </a:prstGeom>
           <a:solidFill>
-            <a:srgbClr val="161617"/>
+            <a:srgbClr val="F5F5F7"/>
           </a:solidFill>
           <a:ln>
             <a:noFill/>
@@ -6361,7 +6361,7 @@
             </a:avLst>
           </a:prstGeom>
           <a:solidFill>
-            <a:srgbClr val="1D1D1F"/>
+            <a:srgbClr val="EAEAED"/>
           </a:solidFill>
           <a:ln w="15875">
             <a:solidFill>
@@ -6390,7 +6390,7 @@
             <a:pPr algn="ctr">
               <a:defRPr sz="1400" b="1">
                 <a:solidFill>
-                  <a:srgbClr val="F5F5F7"/>
+                  <a:srgbClr val="000000"/>
                 </a:solidFill>
               </a:defRPr>
             </a:pPr>
@@ -6452,7 +6452,7 @@
             </a:avLst>
           </a:prstGeom>
           <a:solidFill>
-            <a:srgbClr val="1D1D1F"/>
+            <a:srgbClr val="EAEAED"/>
           </a:solidFill>
           <a:ln w="15875">
             <a:solidFill>
@@ -6481,7 +6481,7 @@
             <a:pPr algn="ctr">
               <a:defRPr sz="1400" b="1">
                 <a:solidFill>
-                  <a:srgbClr val="F5F5F7"/>
+                  <a:srgbClr val="000000"/>
                 </a:solidFill>
               </a:defRPr>
             </a:pPr>
@@ -6543,7 +6543,7 @@
             </a:avLst>
           </a:prstGeom>
           <a:solidFill>
-            <a:srgbClr val="1D1D1F"/>
+            <a:srgbClr val="EAEAED"/>
           </a:solidFill>
           <a:ln w="15875">
             <a:solidFill>
@@ -6572,7 +6572,7 @@
             <a:pPr algn="ctr">
               <a:defRPr sz="1400" b="1">
                 <a:solidFill>
-                  <a:srgbClr val="F5F5F7"/>
+                  <a:srgbClr val="000000"/>
                 </a:solidFill>
               </a:defRPr>
             </a:pPr>
@@ -6638,7 +6638,7 @@
             </a:avLst>
           </a:prstGeom>
           <a:solidFill>
-            <a:srgbClr val="1D1D1F"/>
+            <a:srgbClr val="EAEAED"/>
           </a:solidFill>
           <a:ln w="15875">
             <a:solidFill>
@@ -6667,7 +6667,7 @@
             <a:pPr algn="ctr">
               <a:defRPr sz="1400" b="1">
                 <a:solidFill>
-                  <a:srgbClr val="F5F5F7"/>
+                  <a:srgbClr val="000000"/>
                 </a:solidFill>
               </a:defRPr>
             </a:pPr>
@@ -6733,7 +6733,7 @@
             </a:avLst>
           </a:prstGeom>
           <a:solidFill>
-            <a:srgbClr val="1D1D1F"/>
+            <a:srgbClr val="EAEAED"/>
           </a:solidFill>
           <a:ln w="15875">
             <a:solidFill>
@@ -6762,7 +6762,7 @@
             <a:pPr algn="ctr">
               <a:defRPr sz="1400" b="1">
                 <a:solidFill>
-                  <a:srgbClr val="F5F5F7"/>
+                  <a:srgbClr val="000000"/>
                 </a:solidFill>
               </a:defRPr>
             </a:pPr>
@@ -6786,7 +6786,7 @@
     <p:bg>
       <p:bgPr>
         <a:solidFill>
-          <a:srgbClr val="0B0B0C"/>
+          <a:srgbClr val="FFFFFF"/>
         </a:solidFill>
         <a:effectLst/>
       </p:bgPr>
@@ -6829,7 +6829,7 @@
               </a:spcAft>
               <a:defRPr sz="3800" b="1" i="0">
                 <a:solidFill>
-                  <a:srgbClr val="F5F5F7"/>
+                  <a:srgbClr val="000000"/>
                 </a:solidFill>
                 <a:latin typeface="Helvetica Neue"/>
               </a:defRPr>
@@ -6857,7 +6857,7 @@
             </a:avLst>
           </a:prstGeom>
           <a:solidFill>
-            <a:srgbClr val="1D1D1F"/>
+            <a:srgbClr val="EAEAED"/>
           </a:solidFill>
           <a:ln>
             <a:noFill/>
@@ -6935,7 +6935,7 @@
               </a:spcAft>
               <a:defRPr sz="2000" b="0" i="0">
                 <a:solidFill>
-                  <a:srgbClr val="A1A1A6"/>
+                  <a:srgbClr val="6E6E73"/>
                 </a:solidFill>
                 <a:latin typeface="Helvetica Neue"/>
               </a:defRPr>
@@ -6963,7 +6963,7 @@
             </a:avLst>
           </a:prstGeom>
           <a:solidFill>
-            <a:srgbClr val="1D1D1F"/>
+            <a:srgbClr val="EAEAED"/>
           </a:solidFill>
           <a:ln>
             <a:noFill/>
@@ -7041,7 +7041,7 @@
               </a:spcAft>
               <a:defRPr sz="2000" b="0" i="0">
                 <a:solidFill>
-                  <a:srgbClr val="A1A1A6"/>
+                  <a:srgbClr val="6E6E73"/>
                 </a:solidFill>
                 <a:latin typeface="Helvetica Neue"/>
               </a:defRPr>
@@ -7066,7 +7066,7 @@
     <p:bg>
       <p:bgPr>
         <a:solidFill>
-          <a:srgbClr val="0B0B0C"/>
+          <a:srgbClr val="FFFFFF"/>
         </a:solidFill>
         <a:effectLst/>
       </p:bgPr>
@@ -7109,7 +7109,7 @@
               </a:spcAft>
               <a:defRPr sz="4000" b="1" i="0">
                 <a:solidFill>
-                  <a:srgbClr val="F5F5F7"/>
+                  <a:srgbClr val="000000"/>
                 </a:solidFill>
                 <a:latin typeface="Helvetica Neue"/>
               </a:defRPr>
@@ -7194,7 +7194,7 @@
               </a:spcAft>
               <a:defRPr sz="2800" b="0" i="0">
                 <a:solidFill>
-                  <a:srgbClr val="F5F5F7"/>
+                  <a:srgbClr val="000000"/>
                 </a:solidFill>
                 <a:latin typeface="Helvetica Neue"/>
               </a:defRPr>
@@ -7213,7 +7213,7 @@
               </a:spcAft>
               <a:defRPr sz="2800" b="0" i="0">
                 <a:solidFill>
-                  <a:srgbClr val="F5F5F7"/>
+                  <a:srgbClr val="000000"/>
                 </a:solidFill>
                 <a:latin typeface="Helvetica Neue"/>
               </a:defRPr>
@@ -7232,7 +7232,7 @@
               </a:spcAft>
               <a:defRPr sz="2800" b="0" i="0">
                 <a:solidFill>
-                  <a:srgbClr val="F5F5F7"/>
+                  <a:srgbClr val="000000"/>
                 </a:solidFill>
                 <a:latin typeface="Helvetica Neue"/>
               </a:defRPr>
@@ -7257,7 +7257,7 @@
     <p:bg>
       <p:bgPr>
         <a:solidFill>
-          <a:srgbClr val="0B0B0C"/>
+          <a:srgbClr val="FFFFFF"/>
         </a:solidFill>
         <a:effectLst/>
       </p:bgPr>
@@ -7300,7 +7300,7 @@
               </a:spcAft>
               <a:defRPr sz="13000" b="1" i="0">
                 <a:solidFill>
-                  <a:srgbClr val="F5F5F7"/>
+                  <a:srgbClr val="000000"/>
                 </a:solidFill>
                 <a:latin typeface="Helvetica Neue"/>
               </a:defRPr>
@@ -7319,7 +7319,7 @@
               </a:spcAft>
               <a:defRPr sz="3000" b="0" i="0">
                 <a:solidFill>
-                  <a:srgbClr val="A1A1A6"/>
+                  <a:srgbClr val="6E6E73"/>
                 </a:solidFill>
                 <a:latin typeface="Helvetica Neue"/>
               </a:defRPr>
@@ -7344,7 +7344,7 @@
     <p:bg>
       <p:bgPr>
         <a:solidFill>
-          <a:srgbClr val="0B0B0C"/>
+          <a:srgbClr val="FFFFFF"/>
         </a:solidFill>
         <a:effectLst/>
       </p:bgPr>
@@ -7387,7 +7387,7 @@
               </a:spcAft>
               <a:defRPr sz="3200" b="1" i="0">
                 <a:solidFill>
-                  <a:srgbClr val="F5F5F7"/>
+                  <a:srgbClr val="000000"/>
                 </a:solidFill>
                 <a:latin typeface="Helvetica Neue"/>
               </a:defRPr>
@@ -7415,7 +7415,7 @@
             </a:avLst>
           </a:prstGeom>
           <a:solidFill>
-            <a:srgbClr val="161617"/>
+            <a:srgbClr val="F5F5F7"/>
           </a:solidFill>
           <a:ln>
             <a:noFill/>
@@ -7474,7 +7474,7 @@
               </a:spcAft>
               <a:defRPr sz="1800" b="0" i="0">
                 <a:solidFill>
-                  <a:srgbClr val="F5F5F7"/>
+                  <a:srgbClr val="000000"/>
                 </a:solidFill>
                 <a:latin typeface="Courier New"/>
               </a:defRPr>
@@ -7493,7 +7493,7 @@
               </a:spcAft>
               <a:defRPr sz="1800" b="0" i="0">
                 <a:solidFill>
-                  <a:srgbClr val="F5F5F7"/>
+                  <a:srgbClr val="000000"/>
                 </a:solidFill>
                 <a:latin typeface="Courier New"/>
               </a:defRPr>
@@ -7512,7 +7512,7 @@
               </a:spcAft>
               <a:defRPr sz="1800" b="0" i="0">
                 <a:solidFill>
-                  <a:srgbClr val="F5F5F7"/>
+                  <a:srgbClr val="000000"/>
                 </a:solidFill>
                 <a:latin typeface="Courier New"/>
               </a:defRPr>
@@ -7531,7 +7531,7 @@
               </a:spcAft>
               <a:defRPr sz="1800" b="0" i="0">
                 <a:solidFill>
-                  <a:srgbClr val="F5F5F7"/>
+                  <a:srgbClr val="000000"/>
                 </a:solidFill>
                 <a:latin typeface="Courier New"/>
               </a:defRPr>
@@ -7550,7 +7550,7 @@
               </a:spcAft>
               <a:defRPr sz="1800" b="0" i="0">
                 <a:solidFill>
-                  <a:srgbClr val="F5F5F7"/>
+                  <a:srgbClr val="000000"/>
                 </a:solidFill>
                 <a:latin typeface="Courier New"/>
               </a:defRPr>
@@ -7569,7 +7569,7 @@
               </a:spcAft>
               <a:defRPr sz="1800" b="0" i="0">
                 <a:solidFill>
-                  <a:srgbClr val="F5F5F7"/>
+                  <a:srgbClr val="000000"/>
                 </a:solidFill>
                 <a:latin typeface="Courier New"/>
               </a:defRPr>
@@ -7588,7 +7588,7 @@
               </a:spcAft>
               <a:defRPr sz="1800" b="0" i="0">
                 <a:solidFill>
-                  <a:srgbClr val="F5F5F7"/>
+                  <a:srgbClr val="000000"/>
                 </a:solidFill>
                 <a:latin typeface="Courier New"/>
               </a:defRPr>
@@ -7607,7 +7607,7 @@
               </a:spcAft>
               <a:defRPr sz="1800" b="0" i="0">
                 <a:solidFill>
-                  <a:srgbClr val="F5F5F7"/>
+                  <a:srgbClr val="000000"/>
                 </a:solidFill>
                 <a:latin typeface="Courier New"/>
               </a:defRPr>
@@ -7626,7 +7626,7 @@
               </a:spcAft>
               <a:defRPr sz="1800" b="0" i="0">
                 <a:solidFill>
-                  <a:srgbClr val="F5F5F7"/>
+                  <a:srgbClr val="000000"/>
                 </a:solidFill>
                 <a:latin typeface="Courier New"/>
               </a:defRPr>
@@ -7645,7 +7645,7 @@
               </a:spcAft>
               <a:defRPr sz="1800" b="0" i="0">
                 <a:solidFill>
-                  <a:srgbClr val="F5F5F7"/>
+                  <a:srgbClr val="000000"/>
                 </a:solidFill>
                 <a:latin typeface="Courier New"/>
               </a:defRPr>
@@ -7670,7 +7670,7 @@
     <p:bg>
       <p:bgPr>
         <a:solidFill>
-          <a:srgbClr val="0B0B0C"/>
+          <a:srgbClr val="FFFFFF"/>
         </a:solidFill>
         <a:effectLst/>
       </p:bgPr>
@@ -7713,7 +7713,7 @@
               </a:spcAft>
               <a:defRPr sz="13000" b="1" i="0">
                 <a:solidFill>
-                  <a:srgbClr val="F5F5F7"/>
+                  <a:srgbClr val="000000"/>
                 </a:solidFill>
                 <a:latin typeface="Helvetica Neue"/>
               </a:defRPr>
@@ -7732,7 +7732,7 @@
               </a:spcAft>
               <a:defRPr sz="3000" b="0" i="0">
                 <a:solidFill>
-                  <a:srgbClr val="A1A1A6"/>
+                  <a:srgbClr val="6E6E73"/>
                 </a:solidFill>
                 <a:latin typeface="Helvetica Neue"/>
               </a:defRPr>
@@ -7757,7 +7757,7 @@
     <p:bg>
       <p:bgPr>
         <a:solidFill>
-          <a:srgbClr val="0B0B0C"/>
+          <a:srgbClr val="FFFFFF"/>
         </a:solidFill>
         <a:effectLst/>
       </p:bgPr>
@@ -7800,7 +7800,7 @@
               </a:spcAft>
               <a:defRPr sz="5400" b="1" i="0">
                 <a:solidFill>
-                  <a:srgbClr val="F5F5F7"/>
+                  <a:srgbClr val="000000"/>
                 </a:solidFill>
                 <a:latin typeface="Helvetica Neue"/>
               </a:defRPr>
@@ -7825,7 +7825,7 @@
     <p:bg>
       <p:bgPr>
         <a:solidFill>
-          <a:srgbClr val="0B0B0C"/>
+          <a:srgbClr val="FFFFFF"/>
         </a:solidFill>
         <a:effectLst/>
       </p:bgPr>
@@ -7868,7 +7868,7 @@
               </a:spcAft>
               <a:defRPr sz="4000" b="1" i="0">
                 <a:solidFill>
-                  <a:srgbClr val="F5F5F7"/>
+                  <a:srgbClr val="000000"/>
                 </a:solidFill>
                 <a:latin typeface="Helvetica Neue"/>
               </a:defRPr>
@@ -7953,7 +7953,7 @@
               </a:spcAft>
               <a:defRPr sz="2800" b="0" i="0">
                 <a:solidFill>
-                  <a:srgbClr val="F5F5F7"/>
+                  <a:srgbClr val="000000"/>
                 </a:solidFill>
                 <a:latin typeface="Helvetica Neue"/>
               </a:defRPr>
@@ -7972,7 +7972,7 @@
               </a:spcAft>
               <a:defRPr sz="2800" b="0" i="0">
                 <a:solidFill>
-                  <a:srgbClr val="F5F5F7"/>
+                  <a:srgbClr val="000000"/>
                 </a:solidFill>
                 <a:latin typeface="Helvetica Neue"/>
               </a:defRPr>
@@ -7991,7 +7991,7 @@
               </a:spcAft>
               <a:defRPr sz="2800" b="0" i="0">
                 <a:solidFill>
-                  <a:srgbClr val="F5F5F7"/>
+                  <a:srgbClr val="000000"/>
                 </a:solidFill>
                 <a:latin typeface="Helvetica Neue"/>
               </a:defRPr>
@@ -8016,7 +8016,7 @@
     <p:bg>
       <p:bgPr>
         <a:solidFill>
-          <a:srgbClr val="0B0B0C"/>
+          <a:srgbClr val="FFFFFF"/>
         </a:solidFill>
         <a:effectLst/>
       </p:bgPr>
@@ -8078,7 +8078,7 @@
               </a:spcAft>
               <a:defRPr sz="9600" b="1" i="0">
                 <a:solidFill>
-                  <a:srgbClr val="F5F5F7"/>
+                  <a:srgbClr val="000000"/>
                 </a:solidFill>
                 <a:latin typeface="Helvetica Neue"/>
               </a:defRPr>
@@ -8146,7 +8146,7 @@
     <p:bg>
       <p:bgPr>
         <a:solidFill>
-          <a:srgbClr val="0B0B0C"/>
+          <a:srgbClr val="FFFFFF"/>
         </a:solidFill>
         <a:effectLst/>
       </p:bgPr>
@@ -8189,7 +8189,7 @@
               </a:spcAft>
               <a:defRPr sz="4000" b="1" i="0">
                 <a:solidFill>
-                  <a:srgbClr val="F5F5F7"/>
+                  <a:srgbClr val="000000"/>
                 </a:solidFill>
                 <a:latin typeface="Helvetica Neue"/>
               </a:defRPr>
@@ -8274,7 +8274,7 @@
               </a:spcAft>
               <a:defRPr sz="2800" b="0" i="0">
                 <a:solidFill>
-                  <a:srgbClr val="F5F5F7"/>
+                  <a:srgbClr val="000000"/>
                 </a:solidFill>
                 <a:latin typeface="Helvetica Neue"/>
               </a:defRPr>
@@ -8293,7 +8293,7 @@
               </a:spcAft>
               <a:defRPr sz="2800" b="0" i="0">
                 <a:solidFill>
-                  <a:srgbClr val="F5F5F7"/>
+                  <a:srgbClr val="000000"/>
                 </a:solidFill>
                 <a:latin typeface="Helvetica Neue"/>
               </a:defRPr>
@@ -8312,7 +8312,7 @@
               </a:spcAft>
               <a:defRPr sz="2800" b="0" i="0">
                 <a:solidFill>
-                  <a:srgbClr val="F5F5F7"/>
+                  <a:srgbClr val="000000"/>
                 </a:solidFill>
                 <a:latin typeface="Helvetica Neue"/>
               </a:defRPr>
@@ -8337,7 +8337,7 @@
     <p:bg>
       <p:bgPr>
         <a:solidFill>
-          <a:srgbClr val="0B0B0C"/>
+          <a:srgbClr val="FFFFFF"/>
         </a:solidFill>
         <a:effectLst/>
       </p:bgPr>
@@ -8380,7 +8380,7 @@
               </a:spcAft>
               <a:defRPr sz="4000" b="1" i="0">
                 <a:solidFill>
-                  <a:srgbClr val="F5F5F7"/>
+                  <a:srgbClr val="000000"/>
                 </a:solidFill>
                 <a:latin typeface="Helvetica Neue"/>
               </a:defRPr>
@@ -8465,7 +8465,7 @@
               </a:spcAft>
               <a:defRPr sz="2800" b="0" i="0">
                 <a:solidFill>
-                  <a:srgbClr val="F5F5F7"/>
+                  <a:srgbClr val="000000"/>
                 </a:solidFill>
                 <a:latin typeface="Helvetica Neue"/>
               </a:defRPr>
@@ -8484,7 +8484,7 @@
               </a:spcAft>
               <a:defRPr sz="2800" b="0" i="0">
                 <a:solidFill>
-                  <a:srgbClr val="F5F5F7"/>
+                  <a:srgbClr val="000000"/>
                 </a:solidFill>
                 <a:latin typeface="Helvetica Neue"/>
               </a:defRPr>
@@ -8503,7 +8503,7 @@
               </a:spcAft>
               <a:defRPr sz="2800" b="0" i="0">
                 <a:solidFill>
-                  <a:srgbClr val="F5F5F7"/>
+                  <a:srgbClr val="000000"/>
                 </a:solidFill>
                 <a:latin typeface="Helvetica Neue"/>
               </a:defRPr>
@@ -8528,7 +8528,7 @@
     <p:bg>
       <p:bgPr>
         <a:solidFill>
-          <a:srgbClr val="0B0B0C"/>
+          <a:srgbClr val="FFFFFF"/>
         </a:solidFill>
         <a:effectLst/>
       </p:bgPr>
@@ -8571,7 +8571,7 @@
               </a:spcAft>
               <a:defRPr sz="13000" b="1" i="0">
                 <a:solidFill>
-                  <a:srgbClr val="F5F5F7"/>
+                  <a:srgbClr val="000000"/>
                 </a:solidFill>
                 <a:latin typeface="Helvetica Neue"/>
               </a:defRPr>
@@ -8590,7 +8590,7 @@
               </a:spcAft>
               <a:defRPr sz="3000" b="0" i="0">
                 <a:solidFill>
-                  <a:srgbClr val="A1A1A6"/>
+                  <a:srgbClr val="6E6E73"/>
                 </a:solidFill>
                 <a:latin typeface="Helvetica Neue"/>
               </a:defRPr>
@@ -8615,7 +8615,7 @@
     <p:bg>
       <p:bgPr>
         <a:solidFill>
-          <a:srgbClr val="0B0B0C"/>
+          <a:srgbClr val="FFFFFF"/>
         </a:solidFill>
         <a:effectLst/>
       </p:bgPr>
@@ -8677,7 +8677,7 @@
               </a:spcAft>
               <a:defRPr sz="9600" b="1" i="0">
                 <a:solidFill>
-                  <a:srgbClr val="F5F5F7"/>
+                  <a:srgbClr val="000000"/>
                 </a:solidFill>
                 <a:latin typeface="Helvetica Neue"/>
               </a:defRPr>
@@ -8745,7 +8745,7 @@
     <p:bg>
       <p:bgPr>
         <a:solidFill>
-          <a:srgbClr val="0B0B0C"/>
+          <a:srgbClr val="FFFFFF"/>
         </a:solidFill>
         <a:effectLst/>
       </p:bgPr>
@@ -8788,7 +8788,7 @@
               </a:spcAft>
               <a:defRPr sz="5400" b="1" i="0">
                 <a:solidFill>
-                  <a:srgbClr val="F5F5F7"/>
+                  <a:srgbClr val="000000"/>
                 </a:solidFill>
                 <a:latin typeface="Helvetica Neue"/>
               </a:defRPr>
@@ -8813,7 +8813,7 @@
     <p:bg>
       <p:bgPr>
         <a:solidFill>
-          <a:srgbClr val="0B0B0C"/>
+          <a:srgbClr val="FFFFFF"/>
         </a:solidFill>
         <a:effectLst/>
       </p:bgPr>
@@ -8856,7 +8856,7 @@
               </a:spcAft>
               <a:defRPr sz="4000" b="1" i="0">
                 <a:solidFill>
-                  <a:srgbClr val="F5F5F7"/>
+                  <a:srgbClr val="000000"/>
                 </a:solidFill>
                 <a:latin typeface="Helvetica Neue"/>
               </a:defRPr>
@@ -8941,7 +8941,7 @@
               </a:spcAft>
               <a:defRPr sz="2800" b="0" i="0">
                 <a:solidFill>
-                  <a:srgbClr val="F5F5F7"/>
+                  <a:srgbClr val="000000"/>
                 </a:solidFill>
                 <a:latin typeface="Helvetica Neue"/>
               </a:defRPr>
@@ -8960,7 +8960,7 @@
               </a:spcAft>
               <a:defRPr sz="2800" b="0" i="0">
                 <a:solidFill>
-                  <a:srgbClr val="F5F5F7"/>
+                  <a:srgbClr val="000000"/>
                 </a:solidFill>
                 <a:latin typeface="Helvetica Neue"/>
               </a:defRPr>
@@ -8979,7 +8979,7 @@
               </a:spcAft>
               <a:defRPr sz="2800" b="0" i="0">
                 <a:solidFill>
-                  <a:srgbClr val="F5F5F7"/>
+                  <a:srgbClr val="000000"/>
                 </a:solidFill>
                 <a:latin typeface="Helvetica Neue"/>
               </a:defRPr>
@@ -9004,7 +9004,7 @@
     <p:bg>
       <p:bgPr>
         <a:solidFill>
-          <a:srgbClr val="0B0B0C"/>
+          <a:srgbClr val="FFFFFF"/>
         </a:solidFill>
         <a:effectLst/>
       </p:bgPr>
@@ -9047,7 +9047,7 @@
               </a:spcAft>
               <a:defRPr sz="3800" b="1" i="0">
                 <a:solidFill>
-                  <a:srgbClr val="F5F5F7"/>
+                  <a:srgbClr val="000000"/>
                 </a:solidFill>
                 <a:latin typeface="Helvetica Neue"/>
               </a:defRPr>
@@ -9108,7 +9108,7 @@
               </a:spcAft>
               <a:defRPr sz="2400" b="1" i="0">
                 <a:solidFill>
-                  <a:srgbClr val="F5F5F7"/>
+                  <a:srgbClr val="000000"/>
                 </a:solidFill>
                 <a:latin typeface="Helvetica Neue"/>
               </a:defRPr>
@@ -9127,7 +9127,7 @@
               </a:spcAft>
               <a:defRPr sz="1900" b="0" i="0">
                 <a:solidFill>
-                  <a:srgbClr val="A1A1A6"/>
+                  <a:srgbClr val="6E6E73"/>
                 </a:solidFill>
                 <a:latin typeface="Helvetica Neue"/>
               </a:defRPr>
@@ -9188,7 +9188,7 @@
               </a:spcAft>
               <a:defRPr sz="2400" b="1" i="0">
                 <a:solidFill>
-                  <a:srgbClr val="F5F5F7"/>
+                  <a:srgbClr val="000000"/>
                 </a:solidFill>
                 <a:latin typeface="Helvetica Neue"/>
               </a:defRPr>
@@ -9207,7 +9207,7 @@
               </a:spcAft>
               <a:defRPr sz="1900" b="0" i="0">
                 <a:solidFill>
-                  <a:srgbClr val="A1A1A6"/>
+                  <a:srgbClr val="6E6E73"/>
                 </a:solidFill>
                 <a:latin typeface="Helvetica Neue"/>
               </a:defRPr>
@@ -9268,7 +9268,7 @@
               </a:spcAft>
               <a:defRPr sz="2400" b="1" i="0">
                 <a:solidFill>
-                  <a:srgbClr val="F5F5F7"/>
+                  <a:srgbClr val="000000"/>
                 </a:solidFill>
                 <a:latin typeface="Helvetica Neue"/>
               </a:defRPr>
@@ -9287,7 +9287,7 @@
               </a:spcAft>
               <a:defRPr sz="1900" b="0" i="0">
                 <a:solidFill>
-                  <a:srgbClr val="A1A1A6"/>
+                  <a:srgbClr val="6E6E73"/>
                 </a:solidFill>
                 <a:latin typeface="Helvetica Neue"/>
               </a:defRPr>
@@ -9312,7 +9312,7 @@
     <p:bg>
       <p:bgPr>
         <a:solidFill>
-          <a:srgbClr val="0B0B0C"/>
+          <a:srgbClr val="FFFFFF"/>
         </a:solidFill>
         <a:effectLst/>
       </p:bgPr>
@@ -9355,7 +9355,7 @@
               </a:spcAft>
               <a:defRPr sz="3200" b="1" i="0">
                 <a:solidFill>
-                  <a:srgbClr val="F5F5F7"/>
+                  <a:srgbClr val="000000"/>
                 </a:solidFill>
                 <a:latin typeface="Helvetica Neue"/>
               </a:defRPr>
@@ -9383,7 +9383,7 @@
             </a:avLst>
           </a:prstGeom>
           <a:solidFill>
-            <a:srgbClr val="161617"/>
+            <a:srgbClr val="F5F5F7"/>
           </a:solidFill>
           <a:ln>
             <a:noFill/>
@@ -9442,7 +9442,7 @@
               </a:spcAft>
               <a:defRPr sz="1800" b="0" i="0">
                 <a:solidFill>
-                  <a:srgbClr val="F5F5F7"/>
+                  <a:srgbClr val="000000"/>
                 </a:solidFill>
                 <a:latin typeface="Courier New"/>
               </a:defRPr>
@@ -9461,7 +9461,7 @@
               </a:spcAft>
               <a:defRPr sz="1800" b="0" i="0">
                 <a:solidFill>
-                  <a:srgbClr val="F5F5F7"/>
+                  <a:srgbClr val="000000"/>
                 </a:solidFill>
                 <a:latin typeface="Courier New"/>
               </a:defRPr>
@@ -9480,7 +9480,7 @@
               </a:spcAft>
               <a:defRPr sz="1800" b="0" i="0">
                 <a:solidFill>
-                  <a:srgbClr val="F5F5F7"/>
+                  <a:srgbClr val="000000"/>
                 </a:solidFill>
                 <a:latin typeface="Courier New"/>
               </a:defRPr>
@@ -9499,7 +9499,7 @@
               </a:spcAft>
               <a:defRPr sz="1800" b="0" i="0">
                 <a:solidFill>
-                  <a:srgbClr val="F5F5F7"/>
+                  <a:srgbClr val="000000"/>
                 </a:solidFill>
                 <a:latin typeface="Courier New"/>
               </a:defRPr>
@@ -9518,7 +9518,7 @@
               </a:spcAft>
               <a:defRPr sz="1800" b="0" i="0">
                 <a:solidFill>
-                  <a:srgbClr val="F5F5F7"/>
+                  <a:srgbClr val="000000"/>
                 </a:solidFill>
                 <a:latin typeface="Courier New"/>
               </a:defRPr>
@@ -9537,7 +9537,7 @@
               </a:spcAft>
               <a:defRPr sz="1800" b="0" i="0">
                 <a:solidFill>
-                  <a:srgbClr val="F5F5F7"/>
+                  <a:srgbClr val="000000"/>
                 </a:solidFill>
                 <a:latin typeface="Courier New"/>
               </a:defRPr>
@@ -9556,7 +9556,7 @@
               </a:spcAft>
               <a:defRPr sz="1800" b="0" i="0">
                 <a:solidFill>
-                  <a:srgbClr val="F5F5F7"/>
+                  <a:srgbClr val="000000"/>
                 </a:solidFill>
                 <a:latin typeface="Courier New"/>
               </a:defRPr>
@@ -9575,7 +9575,7 @@
               </a:spcAft>
               <a:defRPr sz="1800" b="0" i="0">
                 <a:solidFill>
-                  <a:srgbClr val="F5F5F7"/>
+                  <a:srgbClr val="000000"/>
                 </a:solidFill>
                 <a:latin typeface="Courier New"/>
               </a:defRPr>
@@ -9594,7 +9594,7 @@
               </a:spcAft>
               <a:defRPr sz="1800" b="0" i="0">
                 <a:solidFill>
-                  <a:srgbClr val="F5F5F7"/>
+                  <a:srgbClr val="000000"/>
                 </a:solidFill>
                 <a:latin typeface="Courier New"/>
               </a:defRPr>
@@ -9613,7 +9613,7 @@
               </a:spcAft>
               <a:defRPr sz="1800" b="0" i="0">
                 <a:solidFill>
-                  <a:srgbClr val="F5F5F7"/>
+                  <a:srgbClr val="000000"/>
                 </a:solidFill>
                 <a:latin typeface="Courier New"/>
               </a:defRPr>
@@ -9638,7 +9638,7 @@
     <p:bg>
       <p:bgPr>
         <a:solidFill>
-          <a:srgbClr val="0B0B0C"/>
+          <a:srgbClr val="FFFFFF"/>
         </a:solidFill>
         <a:effectLst/>
       </p:bgPr>
@@ -9681,7 +9681,7 @@
               </a:spcAft>
               <a:defRPr sz="13000" b="1" i="0">
                 <a:solidFill>
-                  <a:srgbClr val="F5F5F7"/>
+                  <a:srgbClr val="000000"/>
                 </a:solidFill>
                 <a:latin typeface="Helvetica Neue"/>
               </a:defRPr>
@@ -9700,7 +9700,7 @@
               </a:spcAft>
               <a:defRPr sz="3000" b="0" i="0">
                 <a:solidFill>
-                  <a:srgbClr val="A1A1A6"/>
+                  <a:srgbClr val="6E6E73"/>
                 </a:solidFill>
                 <a:latin typeface="Helvetica Neue"/>
               </a:defRPr>
@@ -9725,7 +9725,7 @@
     <p:bg>
       <p:bgPr>
         <a:solidFill>
-          <a:srgbClr val="0B0B0C"/>
+          <a:srgbClr val="FFFFFF"/>
         </a:solidFill>
         <a:effectLst/>
       </p:bgPr>
@@ -9768,7 +9768,7 @@
               </a:spcAft>
               <a:defRPr sz="3800" b="1" i="0">
                 <a:solidFill>
-                  <a:srgbClr val="F5F5F7"/>
+                  <a:srgbClr val="000000"/>
                 </a:solidFill>
                 <a:latin typeface="Helvetica Neue"/>
               </a:defRPr>
@@ -9796,7 +9796,7 @@
             </a:avLst>
           </a:prstGeom>
           <a:solidFill>
-            <a:srgbClr val="1D1D1F"/>
+            <a:srgbClr val="EAEAED"/>
           </a:solidFill>
           <a:ln>
             <a:noFill/>
@@ -9874,7 +9874,7 @@
               </a:spcAft>
               <a:defRPr sz="2000" b="0" i="0">
                 <a:solidFill>
-                  <a:srgbClr val="A1A1A6"/>
+                  <a:srgbClr val="6E6E73"/>
                 </a:solidFill>
                 <a:latin typeface="Helvetica Neue"/>
               </a:defRPr>
@@ -9902,7 +9902,7 @@
             </a:avLst>
           </a:prstGeom>
           <a:solidFill>
-            <a:srgbClr val="1D1D1F"/>
+            <a:srgbClr val="EAEAED"/>
           </a:solidFill>
           <a:ln>
             <a:noFill/>
@@ -9980,7 +9980,7 @@
               </a:spcAft>
               <a:defRPr sz="2000" b="0" i="0">
                 <a:solidFill>
-                  <a:srgbClr val="A1A1A6"/>
+                  <a:srgbClr val="6E6E73"/>
                 </a:solidFill>
                 <a:latin typeface="Helvetica Neue"/>
               </a:defRPr>
@@ -10005,7 +10005,7 @@
     <p:bg>
       <p:bgPr>
         <a:solidFill>
-          <a:srgbClr val="0B0B0C"/>
+          <a:srgbClr val="FFFFFF"/>
         </a:solidFill>
         <a:effectLst/>
       </p:bgPr>
@@ -10067,7 +10067,7 @@
               </a:spcAft>
               <a:defRPr sz="9600" b="1" i="0">
                 <a:solidFill>
-                  <a:srgbClr val="F5F5F7"/>
+                  <a:srgbClr val="000000"/>
                 </a:solidFill>
                 <a:latin typeface="Helvetica Neue"/>
               </a:defRPr>
@@ -10135,7 +10135,7 @@
     <p:bg>
       <p:bgPr>
         <a:solidFill>
-          <a:srgbClr val="0B0B0C"/>
+          <a:srgbClr val="FFFFFF"/>
         </a:solidFill>
         <a:effectLst/>
       </p:bgPr>
@@ -10178,7 +10178,7 @@
               </a:spcAft>
               <a:defRPr sz="4000" b="1" i="0">
                 <a:solidFill>
-                  <a:srgbClr val="F5F5F7"/>
+                  <a:srgbClr val="000000"/>
                 </a:solidFill>
                 <a:latin typeface="Helvetica Neue"/>
               </a:defRPr>
@@ -10263,7 +10263,7 @@
               </a:spcAft>
               <a:defRPr sz="2800" b="0" i="0">
                 <a:solidFill>
-                  <a:srgbClr val="F5F5F7"/>
+                  <a:srgbClr val="000000"/>
                 </a:solidFill>
                 <a:latin typeface="Helvetica Neue"/>
               </a:defRPr>
@@ -10282,7 +10282,7 @@
               </a:spcAft>
               <a:defRPr sz="2800" b="0" i="0">
                 <a:solidFill>
-                  <a:srgbClr val="F5F5F7"/>
+                  <a:srgbClr val="000000"/>
                 </a:solidFill>
                 <a:latin typeface="Helvetica Neue"/>
               </a:defRPr>
@@ -10301,7 +10301,7 @@
               </a:spcAft>
               <a:defRPr sz="2800" b="0" i="0">
                 <a:solidFill>
-                  <a:srgbClr val="F5F5F7"/>
+                  <a:srgbClr val="000000"/>
                 </a:solidFill>
                 <a:latin typeface="Helvetica Neue"/>
               </a:defRPr>
@@ -10326,7 +10326,7 @@
     <p:bg>
       <p:bgPr>
         <a:solidFill>
-          <a:srgbClr val="0B0B0C"/>
+          <a:srgbClr val="FFFFFF"/>
         </a:solidFill>
         <a:effectLst/>
       </p:bgPr>
@@ -10369,7 +10369,7 @@
               </a:spcAft>
               <a:defRPr sz="4000" b="1" i="0">
                 <a:solidFill>
-                  <a:srgbClr val="F5F5F7"/>
+                  <a:srgbClr val="000000"/>
                 </a:solidFill>
                 <a:latin typeface="Helvetica Neue"/>
               </a:defRPr>
@@ -10454,7 +10454,7 @@
               </a:spcAft>
               <a:defRPr sz="2800" b="0" i="0">
                 <a:solidFill>
-                  <a:srgbClr val="F5F5F7"/>
+                  <a:srgbClr val="000000"/>
                 </a:solidFill>
                 <a:latin typeface="Helvetica Neue"/>
               </a:defRPr>
@@ -10473,7 +10473,7 @@
               </a:spcAft>
               <a:defRPr sz="2800" b="0" i="0">
                 <a:solidFill>
-                  <a:srgbClr val="F5F5F7"/>
+                  <a:srgbClr val="000000"/>
                 </a:solidFill>
                 <a:latin typeface="Helvetica Neue"/>
               </a:defRPr>
@@ -10492,7 +10492,7 @@
               </a:spcAft>
               <a:defRPr sz="2800" b="0" i="0">
                 <a:solidFill>
-                  <a:srgbClr val="F5F5F7"/>
+                  <a:srgbClr val="000000"/>
                 </a:solidFill>
                 <a:latin typeface="Helvetica Neue"/>
               </a:defRPr>
@@ -10517,7 +10517,7 @@
     <p:bg>
       <p:bgPr>
         <a:solidFill>
-          <a:srgbClr val="0B0B0C"/>
+          <a:srgbClr val="FFFFFF"/>
         </a:solidFill>
         <a:effectLst/>
       </p:bgPr>
@@ -10560,7 +10560,7 @@
               </a:spcAft>
               <a:defRPr sz="3800" b="1" i="0">
                 <a:solidFill>
-                  <a:srgbClr val="F5F5F7"/>
+                  <a:srgbClr val="000000"/>
                 </a:solidFill>
                 <a:latin typeface="Helvetica Neue"/>
               </a:defRPr>
@@ -10588,7 +10588,7 @@
             </a:avLst>
           </a:prstGeom>
           <a:solidFill>
-            <a:srgbClr val="161617"/>
+            <a:srgbClr val="F5F5F7"/>
           </a:solidFill>
           <a:ln>
             <a:noFill/>
@@ -10633,7 +10633,7 @@
             </a:avLst>
           </a:prstGeom>
           <a:solidFill>
-            <a:srgbClr val="1D1D1F"/>
+            <a:srgbClr val="EAEAED"/>
           </a:solidFill>
           <a:ln w="15875">
             <a:solidFill>
@@ -10662,7 +10662,7 @@
             <a:pPr algn="ctr">
               <a:defRPr sz="1400" b="1">
                 <a:solidFill>
-                  <a:srgbClr val="F5F5F7"/>
+                  <a:srgbClr val="000000"/>
                 </a:solidFill>
               </a:defRPr>
             </a:pPr>
@@ -10728,7 +10728,7 @@
             </a:avLst>
           </a:prstGeom>
           <a:solidFill>
-            <a:srgbClr val="1D1D1F"/>
+            <a:srgbClr val="EAEAED"/>
           </a:solidFill>
           <a:ln w="15875">
             <a:solidFill>
@@ -10757,7 +10757,7 @@
             <a:pPr algn="ctr">
               <a:defRPr sz="1400" b="1">
                 <a:solidFill>
-                  <a:srgbClr val="F5F5F7"/>
+                  <a:srgbClr val="000000"/>
                 </a:solidFill>
               </a:defRPr>
             </a:pPr>
@@ -10823,7 +10823,7 @@
             </a:avLst>
           </a:prstGeom>
           <a:solidFill>
-            <a:srgbClr val="1D1D1F"/>
+            <a:srgbClr val="EAEAED"/>
           </a:solidFill>
           <a:ln w="15875">
             <a:solidFill>
@@ -10852,7 +10852,7 @@
             <a:pPr algn="ctr">
               <a:defRPr sz="1400" b="1">
                 <a:solidFill>
-                  <a:srgbClr val="F5F5F7"/>
+                  <a:srgbClr val="000000"/>
                 </a:solidFill>
               </a:defRPr>
             </a:pPr>
@@ -10918,7 +10918,7 @@
             </a:avLst>
           </a:prstGeom>
           <a:solidFill>
-            <a:srgbClr val="1D1D1F"/>
+            <a:srgbClr val="EAEAED"/>
           </a:solidFill>
           <a:ln w="15875">
             <a:solidFill>
@@ -10947,7 +10947,7 @@
             <a:pPr algn="ctr">
               <a:defRPr sz="1400" b="1">
                 <a:solidFill>
-                  <a:srgbClr val="F5F5F7"/>
+                  <a:srgbClr val="000000"/>
                 </a:solidFill>
               </a:defRPr>
             </a:pPr>
@@ -11013,7 +11013,7 @@
             </a:avLst>
           </a:prstGeom>
           <a:solidFill>
-            <a:srgbClr val="1D1D1F"/>
+            <a:srgbClr val="EAEAED"/>
           </a:solidFill>
           <a:ln w="15875">
             <a:solidFill>
@@ -11042,7 +11042,7 @@
             <a:pPr algn="ctr">
               <a:defRPr sz="1400" b="1">
                 <a:solidFill>
-                  <a:srgbClr val="F5F5F7"/>
+                  <a:srgbClr val="000000"/>
                 </a:solidFill>
               </a:defRPr>
             </a:pPr>
@@ -11066,7 +11066,7 @@
     <p:bg>
       <p:bgPr>
         <a:solidFill>
-          <a:srgbClr val="0B0B0C"/>
+          <a:srgbClr val="FFFFFF"/>
         </a:solidFill>
         <a:effectLst/>
       </p:bgPr>
@@ -11109,7 +11109,7 @@
               </a:spcAft>
               <a:defRPr sz="5400" b="1" i="0">
                 <a:solidFill>
-                  <a:srgbClr val="F5F5F7"/>
+                  <a:srgbClr val="000000"/>
                 </a:solidFill>
                 <a:latin typeface="Helvetica Neue"/>
               </a:defRPr>
@@ -11134,7 +11134,7 @@
     <p:bg>
       <p:bgPr>
         <a:solidFill>
-          <a:srgbClr val="0B0B0C"/>
+          <a:srgbClr val="FFFFFF"/>
         </a:solidFill>
         <a:effectLst/>
       </p:bgPr>
@@ -11177,7 +11177,7 @@
               </a:spcAft>
               <a:defRPr sz="3800" b="0" i="1">
                 <a:solidFill>
-                  <a:srgbClr val="F5F5F7"/>
+                  <a:srgbClr val="000000"/>
                 </a:solidFill>
                 <a:latin typeface="Helvetica Neue"/>
               </a:defRPr>
@@ -11196,7 +11196,7 @@
               </a:spcAft>
               <a:defRPr sz="2000" b="0" i="0">
                 <a:solidFill>
-                  <a:srgbClr val="A1A1A6"/>
+                  <a:srgbClr val="6E6E73"/>
                 </a:solidFill>
                 <a:latin typeface="Helvetica Neue"/>
               </a:defRPr>
@@ -11221,7 +11221,7 @@
     <p:bg>
       <p:bgPr>
         <a:solidFill>
-          <a:srgbClr val="0B0B0C"/>
+          <a:srgbClr val="FFFFFF"/>
         </a:solidFill>
         <a:effectLst/>
       </p:bgPr>
@@ -11264,7 +11264,7 @@
               </a:spcAft>
               <a:defRPr sz="5400" b="1" i="0">
                 <a:solidFill>
-                  <a:srgbClr val="F5F5F7"/>
+                  <a:srgbClr val="000000"/>
                 </a:solidFill>
                 <a:latin typeface="Helvetica Neue"/>
               </a:defRPr>
@@ -11289,7 +11289,7 @@
     <p:bg>
       <p:bgPr>
         <a:solidFill>
-          <a:srgbClr val="0B0B0C"/>
+          <a:srgbClr val="FFFFFF"/>
         </a:solidFill>
         <a:effectLst/>
       </p:bgPr>
@@ -11332,7 +11332,7 @@
               </a:spcAft>
               <a:defRPr sz="4000" b="1" i="0">
                 <a:solidFill>
-                  <a:srgbClr val="F5F5F7"/>
+                  <a:srgbClr val="000000"/>
                 </a:solidFill>
                 <a:latin typeface="Helvetica Neue"/>
               </a:defRPr>
@@ -11417,7 +11417,7 @@
               </a:spcAft>
               <a:defRPr sz="2800" b="0" i="0">
                 <a:solidFill>
-                  <a:srgbClr val="F5F5F7"/>
+                  <a:srgbClr val="000000"/>
                 </a:solidFill>
                 <a:latin typeface="Helvetica Neue"/>
               </a:defRPr>
@@ -11436,7 +11436,7 @@
               </a:spcAft>
               <a:defRPr sz="2800" b="0" i="0">
                 <a:solidFill>
-                  <a:srgbClr val="F5F5F7"/>
+                  <a:srgbClr val="000000"/>
                 </a:solidFill>
                 <a:latin typeface="Helvetica Neue"/>
               </a:defRPr>
@@ -11455,7 +11455,7 @@
               </a:spcAft>
               <a:defRPr sz="2800" b="0" i="0">
                 <a:solidFill>
-                  <a:srgbClr val="F5F5F7"/>
+                  <a:srgbClr val="000000"/>
                 </a:solidFill>
                 <a:latin typeface="Helvetica Neue"/>
               </a:defRPr>
@@ -11480,7 +11480,7 @@
     <p:bg>
       <p:bgPr>
         <a:solidFill>
-          <a:srgbClr val="0B0B0C"/>
+          <a:srgbClr val="FFFFFF"/>
         </a:solidFill>
         <a:effectLst/>
       </p:bgPr>
@@ -11523,7 +11523,7 @@
               </a:spcAft>
               <a:defRPr sz="7200" b="1" i="0">
                 <a:solidFill>
-                  <a:srgbClr val="F5F5F7"/>
+                  <a:srgbClr val="000000"/>
                 </a:solidFill>
                 <a:latin typeface="Helvetica Neue"/>
               </a:defRPr>
@@ -11542,7 +11542,7 @@
               </a:spcAft>
               <a:defRPr sz="2600" b="0" i="0">
                 <a:solidFill>
-                  <a:srgbClr val="A1A1A6"/>
+                  <a:srgbClr val="6E6E73"/>
                 </a:solidFill>
                 <a:latin typeface="Helvetica Neue"/>
               </a:defRPr>

</xml_diff>